<commit_message>
Finished the actual work
Finishing filling out the pwoerpoint that had the assignment problems in
it
</commit_message>
<xml_diff>
--- a/Handouts/Tree lab.pptx
+++ b/Handouts/Tree lab.pptx
@@ -4115,7 +4115,7 @@
         <p:spPr bwMode="auto">
           <a:xfrm>
             <a:off x="822325" y="4227513"/>
-            <a:ext cx="4067588" cy="2123658"/>
+            <a:ext cx="4067588" cy="1569660"/>
           </a:xfrm>
           <a:prstGeom prst="rect">
             <a:avLst/>
@@ -4281,14 +4281,6 @@
               <a:rPr lang="en-US" sz="1200" dirty="0">
                 <a:latin typeface="Times New Roman" pitchFamily="18" charset="0"/>
               </a:rPr>
-              <a:t> 16 34 35 38 39 41 44 45 55 63 64 65 72 </a:t>
-            </a:r>
-          </a:p>
-          <a:p>
-            <a:r>
-              <a:rPr lang="en-US" sz="1200" dirty="0">
-                <a:latin typeface="Times New Roman" pitchFamily="18" charset="0"/>
-              </a:rPr>
               <a:t>	</a:t>
             </a:r>
           </a:p>
@@ -4298,14 +4290,6 @@
                 <a:latin typeface="Times New Roman" pitchFamily="18" charset="0"/>
               </a:rPr>
               <a:t>(b)  What is the preorder traversal of the tree?</a:t>
-            </a:r>
-          </a:p>
-          <a:p>
-            <a:r>
-              <a:rPr lang="en-US" sz="1200" dirty="0">
-                <a:latin typeface="Times New Roman" pitchFamily="18" charset="0"/>
-              </a:rPr>
-              <a:t>45 38 34 16 35 41 39 44 65 63 55 64 72          </a:t>
             </a:r>
           </a:p>
           <a:p>
@@ -4331,14 +4315,6 @@
                 <a:latin typeface="Times New Roman" pitchFamily="18" charset="0"/>
               </a:rPr>
               <a:t> traversal of the tree?</a:t>
-            </a:r>
-          </a:p>
-          <a:p>
-            <a:r>
-              <a:rPr lang="en-US" sz="1200" dirty="0">
-                <a:latin typeface="Times New Roman" pitchFamily="18" charset="0"/>
-              </a:rPr>
-              <a:t>16 35 34 39 44 41 38 55 64 63 72 65 45         </a:t>
             </a:r>
           </a:p>
           <a:p>

</xml_diff>